<commit_message>
Update the deck with market intelligence details on data quality
</commit_message>
<xml_diff>
--- a/Address_Intelligence_Demo.pptx
+++ b/Address_Intelligence_Demo.pptx
@@ -107,6 +107,11 @@
       </a:defRPr>
     </a:lvl9pPr>
   </p:defaultTextStyle>
+  <p:extLst>
+    <p:ext uri="{EFAFB233-063F-42B5-8137-9DF3F51BA10A}">
+      <p15:sldGuideLst xmlns:p15="http://schemas.microsoft.com/office/powerpoint/2012/main"/>
+    </p:ext>
+  </p:extLst>
 </p:presentation>
 </file>
 
@@ -3955,7 +3960,7 @@
           <a:p>
             <a:fld id="{6EAA1C72-6D7D-8444-AE08-34203D582B78}" type="datetimeFigureOut">
               <a:rPr lang="en-US" smtClean="0"/>
-              <a:t>5/11/26</a:t>
+              <a:t>5/12/26</a:t>
             </a:fld>
             <a:endParaRPr lang="en-US"/>
           </a:p>
@@ -4153,7 +4158,7 @@
           <a:p>
             <a:fld id="{6EAA1C72-6D7D-8444-AE08-34203D582B78}" type="datetimeFigureOut">
               <a:rPr lang="en-US" smtClean="0"/>
-              <a:t>5/11/26</a:t>
+              <a:t>5/12/26</a:t>
             </a:fld>
             <a:endParaRPr lang="en-US"/>
           </a:p>
@@ -4361,7 +4366,7 @@
           <a:p>
             <a:fld id="{6EAA1C72-6D7D-8444-AE08-34203D582B78}" type="datetimeFigureOut">
               <a:rPr lang="en-US" smtClean="0"/>
-              <a:t>5/11/26</a:t>
+              <a:t>5/12/26</a:t>
             </a:fld>
             <a:endParaRPr lang="en-US"/>
           </a:p>
@@ -4559,7 +4564,7 @@
           <a:p>
             <a:fld id="{6EAA1C72-6D7D-8444-AE08-34203D582B78}" type="datetimeFigureOut">
               <a:rPr lang="en-US" smtClean="0"/>
-              <a:t>5/11/26</a:t>
+              <a:t>5/12/26</a:t>
             </a:fld>
             <a:endParaRPr lang="en-US"/>
           </a:p>
@@ -4834,7 +4839,7 @@
           <a:p>
             <a:fld id="{6EAA1C72-6D7D-8444-AE08-34203D582B78}" type="datetimeFigureOut">
               <a:rPr lang="en-US" smtClean="0"/>
-              <a:t>5/11/26</a:t>
+              <a:t>5/12/26</a:t>
             </a:fld>
             <a:endParaRPr lang="en-US"/>
           </a:p>
@@ -5099,7 +5104,7 @@
           <a:p>
             <a:fld id="{6EAA1C72-6D7D-8444-AE08-34203D582B78}" type="datetimeFigureOut">
               <a:rPr lang="en-US" smtClean="0"/>
-              <a:t>5/11/26</a:t>
+              <a:t>5/12/26</a:t>
             </a:fld>
             <a:endParaRPr lang="en-US"/>
           </a:p>
@@ -5511,7 +5516,7 @@
           <a:p>
             <a:fld id="{6EAA1C72-6D7D-8444-AE08-34203D582B78}" type="datetimeFigureOut">
               <a:rPr lang="en-US" smtClean="0"/>
-              <a:t>5/11/26</a:t>
+              <a:t>5/12/26</a:t>
             </a:fld>
             <a:endParaRPr lang="en-US"/>
           </a:p>
@@ -5652,7 +5657,7 @@
           <a:p>
             <a:fld id="{6EAA1C72-6D7D-8444-AE08-34203D582B78}" type="datetimeFigureOut">
               <a:rPr lang="en-US" smtClean="0"/>
-              <a:t>5/11/26</a:t>
+              <a:t>5/12/26</a:t>
             </a:fld>
             <a:endParaRPr lang="en-US"/>
           </a:p>
@@ -5765,7 +5770,7 @@
           <a:p>
             <a:fld id="{6EAA1C72-6D7D-8444-AE08-34203D582B78}" type="datetimeFigureOut">
               <a:rPr lang="en-US" smtClean="0"/>
-              <a:t>5/11/26</a:t>
+              <a:t>5/12/26</a:t>
             </a:fld>
             <a:endParaRPr lang="en-US"/>
           </a:p>
@@ -6076,7 +6081,7 @@
           <a:p>
             <a:fld id="{6EAA1C72-6D7D-8444-AE08-34203D582B78}" type="datetimeFigureOut">
               <a:rPr lang="en-US" smtClean="0"/>
-              <a:t>5/11/26</a:t>
+              <a:t>5/12/26</a:t>
             </a:fld>
             <a:endParaRPr lang="en-US"/>
           </a:p>
@@ -6364,7 +6369,7 @@
           <a:p>
             <a:fld id="{6EAA1C72-6D7D-8444-AE08-34203D582B78}" type="datetimeFigureOut">
               <a:rPr lang="en-US" smtClean="0"/>
-              <a:t>5/11/26</a:t>
+              <a:t>5/12/26</a:t>
             </a:fld>
             <a:endParaRPr lang="en-US"/>
           </a:p>
@@ -6605,7 +6610,7 @@
           <a:p>
             <a:fld id="{6EAA1C72-6D7D-8444-AE08-34203D582B78}" type="datetimeFigureOut">
               <a:rPr lang="en-US" smtClean="0"/>
-              <a:t>5/11/26</a:t>
+              <a:t>5/12/26</a:t>
             </a:fld>
             <a:endParaRPr lang="en-US"/>
           </a:p>
@@ -7629,7 +7634,7 @@
         </p:spPr>
         <p:txBody>
           <a:bodyPr anchor="ctr">
-            <a:normAutofit/>
+            <a:normAutofit fontScale="90000"/>
           </a:bodyPr>
           <a:lstStyle/>
           <a:p>
@@ -7642,9 +7647,8 @@
             </a:br>
             <a:r>
               <a:rPr lang="en-US" sz="2200" dirty="0"/>
-              <a:t>A mid-sized carrier with 300,000+ policyholders. ~20% of records may have bad address data.</a:t>
+              <a:t>A mid-sized carrier with 300,000+ policyholders. Industry research indicates that only 24% of insurance data leaders are highly confident in their data accuracy (Corium Intelligence, 2024).</a:t>
             </a:r>
-            <a:endParaRPr lang="en-US" dirty="0"/>
           </a:p>
         </p:txBody>
       </p:sp>
@@ -7865,6 +7869,41 @@
                 </a:solidFill>
               </a:rPr>
               <a:t>THE PROBLEM</a:t>
+            </a:r>
+          </a:p>
+        </p:txBody>
+      </p:sp>
+      <p:sp>
+        <p:nvSpPr>
+          <p:cNvPr id="5" name="TextBox 4">
+            <a:extLst>
+              <a:ext uri="{FF2B5EF4-FFF2-40B4-BE49-F238E27FC236}">
+                <a16:creationId xmlns:a16="http://schemas.microsoft.com/office/drawing/2014/main" id="{DAF87842-03B3-134F-435F-8B1526938971}"/>
+              </a:ext>
+            </a:extLst>
+          </p:cNvPr>
+          <p:cNvSpPr txBox="1"/>
+          <p:nvPr/>
+        </p:nvSpPr>
+        <p:spPr>
+          <a:xfrm>
+            <a:off x="4199709" y="6095401"/>
+            <a:ext cx="7154092" cy="246220"/>
+          </a:xfrm>
+          <a:prstGeom prst="rect">
+            <a:avLst/>
+          </a:prstGeom>
+          <a:noFill/>
+        </p:spPr>
+        <p:txBody>
+          <a:bodyPr wrap="square" rtlCol="0">
+            <a:spAutoFit/>
+          </a:bodyPr>
+          <a:lstStyle/>
+          <a:p>
+            <a:r>
+              <a:rPr lang="en-US" sz="1000" dirty="0"/>
+              <a:t>The 22% bad data rate used in prototype is illustrative — actual rates vary by carrier, system age, and data entry controls.</a:t>
             </a:r>
           </a:p>
         </p:txBody>

</xml_diff>